<commit_message>
Pushed week3.day1 code FYR
</commit_message>
<xml_diff>
--- a/Reference_Documents/ppts/Testing_GET_endpoint_with_RestAssured_Java_Library.pptx
+++ b/Reference_Documents/ppts/Testing_GET_endpoint_with_RestAssured_Java_Library.pptx
@@ -9,24 +9,25 @@
     <p:sldId id="295" r:id="rId6"/>
     <p:sldId id="297" r:id="rId7"/>
     <p:sldId id="296" r:id="rId8"/>
-    <p:sldId id="269" r:id="rId9"/>
-    <p:sldId id="278" r:id="rId10"/>
-    <p:sldId id="273" r:id="rId11"/>
-    <p:sldId id="282" r:id="rId12"/>
-    <p:sldId id="277" r:id="rId13"/>
-    <p:sldId id="268" r:id="rId14"/>
-    <p:sldId id="284" r:id="rId15"/>
-    <p:sldId id="283" r:id="rId16"/>
-    <p:sldId id="281" r:id="rId17"/>
-    <p:sldId id="293" r:id="rId18"/>
-    <p:sldId id="285" r:id="rId19"/>
-    <p:sldId id="291" r:id="rId20"/>
-    <p:sldId id="286" r:id="rId21"/>
-    <p:sldId id="287" r:id="rId22"/>
-    <p:sldId id="288" r:id="rId23"/>
-    <p:sldId id="289" r:id="rId24"/>
-    <p:sldId id="290" r:id="rId25"/>
-    <p:sldId id="292" r:id="rId26"/>
+    <p:sldId id="298" r:id="rId9"/>
+    <p:sldId id="269" r:id="rId10"/>
+    <p:sldId id="278" r:id="rId11"/>
+    <p:sldId id="273" r:id="rId12"/>
+    <p:sldId id="282" r:id="rId13"/>
+    <p:sldId id="277" r:id="rId14"/>
+    <p:sldId id="268" r:id="rId15"/>
+    <p:sldId id="284" r:id="rId16"/>
+    <p:sldId id="283" r:id="rId17"/>
+    <p:sldId id="281" r:id="rId18"/>
+    <p:sldId id="293" r:id="rId19"/>
+    <p:sldId id="285" r:id="rId20"/>
+    <p:sldId id="291" r:id="rId21"/>
+    <p:sldId id="286" r:id="rId22"/>
+    <p:sldId id="287" r:id="rId23"/>
+    <p:sldId id="288" r:id="rId24"/>
+    <p:sldId id="289" r:id="rId25"/>
+    <p:sldId id="290" r:id="rId26"/>
+    <p:sldId id="292" r:id="rId27"/>
   </p:sldIdLst>
   <p:sldSz cx="12192000" cy="6858000"/>
   <p:notesSz cx="6858000" cy="9144000"/>
@@ -362,7 +363,7 @@
           <a:p>
             <a:fld id="{B20382E0-383C-40BD-B191-2EE3638CD38D}" type="datetimeFigureOut">
               <a:rPr lang="en-US" smtClean="0"/>
-              <a:t>10/4/2025</a:t>
+              <a:t>3/26/2026</a:t>
             </a:fld>
             <a:endParaRPr lang="en-US" dirty="0"/>
           </a:p>
@@ -695,7 +696,7 @@
           <a:p>
             <a:fld id="{B20382E0-383C-40BD-B191-2EE3638CD38D}" type="datetimeFigureOut">
               <a:rPr lang="en-US" smtClean="0"/>
-              <a:t>10/4/2025</a:t>
+              <a:t>3/26/2026</a:t>
             </a:fld>
             <a:endParaRPr lang="en-US" dirty="0"/>
           </a:p>
@@ -973,7 +974,7 @@
           <a:p>
             <a:fld id="{B20382E0-383C-40BD-B191-2EE3638CD38D}" type="datetimeFigureOut">
               <a:rPr lang="en-US" smtClean="0"/>
-              <a:t>10/4/2025</a:t>
+              <a:t>3/26/2026</a:t>
             </a:fld>
             <a:endParaRPr lang="en-US" dirty="0"/>
           </a:p>
@@ -1541,7 +1542,7 @@
           <a:p>
             <a:fld id="{B20382E0-383C-40BD-B191-2EE3638CD38D}" type="datetimeFigureOut">
               <a:rPr lang="en-US" smtClean="0"/>
-              <a:t>10/4/2025</a:t>
+              <a:t>3/26/2026</a:t>
             </a:fld>
             <a:endParaRPr lang="en-US" dirty="0"/>
           </a:p>
@@ -1819,7 +1820,7 @@
           <a:p>
             <a:fld id="{B20382E0-383C-40BD-B191-2EE3638CD38D}" type="datetimeFigureOut">
               <a:rPr lang="en-US" smtClean="0"/>
-              <a:t>10/4/2025</a:t>
+              <a:t>3/26/2026</a:t>
             </a:fld>
             <a:endParaRPr lang="en-US" dirty="0"/>
           </a:p>
@@ -2381,7 +2382,7 @@
           <a:p>
             <a:fld id="{B20382E0-383C-40BD-B191-2EE3638CD38D}" type="datetimeFigureOut">
               <a:rPr lang="en-US" smtClean="0"/>
-              <a:t>10/4/2025</a:t>
+              <a:t>3/26/2026</a:t>
             </a:fld>
             <a:endParaRPr lang="en-US" dirty="0"/>
           </a:p>
@@ -2708,7 +2709,7 @@
           <a:p>
             <a:fld id="{B20382E0-383C-40BD-B191-2EE3638CD38D}" type="datetimeFigureOut">
               <a:rPr lang="en-US" smtClean="0"/>
-              <a:t>10/4/2025</a:t>
+              <a:t>3/26/2026</a:t>
             </a:fld>
             <a:endParaRPr lang="en-US" dirty="0"/>
           </a:p>
@@ -2885,7 +2886,7 @@
           <a:p>
             <a:fld id="{B20382E0-383C-40BD-B191-2EE3638CD38D}" type="datetimeFigureOut">
               <a:rPr lang="en-US" smtClean="0"/>
-              <a:t>10/4/2025</a:t>
+              <a:t>3/26/2026</a:t>
             </a:fld>
             <a:endParaRPr lang="en-US" dirty="0"/>
           </a:p>
@@ -3123,7 +3124,7 @@
           <a:p>
             <a:fld id="{B20382E0-383C-40BD-B191-2EE3638CD38D}" type="datetimeFigureOut">
               <a:rPr lang="en-US" smtClean="0"/>
-              <a:t>10/4/2025</a:t>
+              <a:t>3/26/2026</a:t>
             </a:fld>
             <a:endParaRPr lang="en-US" dirty="0"/>
           </a:p>
@@ -3323,7 +3324,7 @@
           <a:p>
             <a:fld id="{B20382E0-383C-40BD-B191-2EE3638CD38D}" type="datetimeFigureOut">
               <a:rPr lang="en-US" smtClean="0"/>
-              <a:t>10/4/2025</a:t>
+              <a:t>3/26/2026</a:t>
             </a:fld>
             <a:endParaRPr lang="en-US" dirty="0"/>
           </a:p>
@@ -3599,7 +3600,7 @@
           <a:p>
             <a:fld id="{B20382E0-383C-40BD-B191-2EE3638CD38D}" type="datetimeFigureOut">
               <a:rPr lang="en-US" smtClean="0"/>
-              <a:t>10/4/2025</a:t>
+              <a:t>3/26/2026</a:t>
             </a:fld>
             <a:endParaRPr lang="en-US" dirty="0"/>
           </a:p>
@@ -3865,7 +3866,7 @@
           <a:p>
             <a:fld id="{B20382E0-383C-40BD-B191-2EE3638CD38D}" type="datetimeFigureOut">
               <a:rPr lang="en-US" smtClean="0"/>
-              <a:t>10/4/2025</a:t>
+              <a:t>3/26/2026</a:t>
             </a:fld>
             <a:endParaRPr lang="en-US" dirty="0"/>
           </a:p>
@@ -4239,7 +4240,7 @@
           <a:p>
             <a:fld id="{B20382E0-383C-40BD-B191-2EE3638CD38D}" type="datetimeFigureOut">
               <a:rPr lang="en-US" smtClean="0"/>
-              <a:t>10/4/2025</a:t>
+              <a:t>3/26/2026</a:t>
             </a:fld>
             <a:endParaRPr lang="en-US" dirty="0"/>
           </a:p>
@@ -4387,7 +4388,7 @@
           <a:p>
             <a:fld id="{B20382E0-383C-40BD-B191-2EE3638CD38D}" type="datetimeFigureOut">
               <a:rPr lang="en-US" smtClean="0"/>
-              <a:t>10/4/2025</a:t>
+              <a:t>3/26/2026</a:t>
             </a:fld>
             <a:endParaRPr lang="en-US" dirty="0"/>
           </a:p>
@@ -4512,7 +4513,7 @@
           <a:p>
             <a:fld id="{B20382E0-383C-40BD-B191-2EE3638CD38D}" type="datetimeFigureOut">
               <a:rPr lang="en-US" smtClean="0"/>
-              <a:t>10/4/2025</a:t>
+              <a:t>3/26/2026</a:t>
             </a:fld>
             <a:endParaRPr lang="en-US" dirty="0"/>
           </a:p>
@@ -4797,7 +4798,7 @@
           <a:p>
             <a:fld id="{B20382E0-383C-40BD-B191-2EE3638CD38D}" type="datetimeFigureOut">
               <a:rPr lang="en-US" smtClean="0"/>
-              <a:t>10/4/2025</a:t>
+              <a:t>3/26/2026</a:t>
             </a:fld>
             <a:endParaRPr lang="en-US" dirty="0"/>
           </a:p>
@@ -5120,7 +5121,7 @@
           <a:p>
             <a:fld id="{B20382E0-383C-40BD-B191-2EE3638CD38D}" type="datetimeFigureOut">
               <a:rPr lang="en-US" smtClean="0"/>
-              <a:t>10/4/2025</a:t>
+              <a:t>3/26/2026</a:t>
             </a:fld>
             <a:endParaRPr lang="en-US" dirty="0"/>
           </a:p>
@@ -5334,7 +5335,7 @@
           <a:p>
             <a:fld id="{B20382E0-383C-40BD-B191-2EE3638CD38D}" type="datetimeFigureOut">
               <a:rPr lang="en-US" smtClean="0"/>
-              <a:t>10/4/2025</a:t>
+              <a:t>3/26/2026</a:t>
             </a:fld>
             <a:endParaRPr lang="en-US" dirty="0"/>
           </a:p>
@@ -5915,6 +5916,157 @@
 <file path=ppt/slides/slide10.xml><?xml version="1.0" encoding="utf-8"?>
 <p:sld xmlns:a="http://schemas.openxmlformats.org/drawingml/2006/main" xmlns:r="http://schemas.openxmlformats.org/officeDocument/2006/relationships" xmlns:p="http://schemas.openxmlformats.org/presentationml/2006/main">
   <p:cSld>
+    <p:spTree>
+      <p:nvGrpSpPr>
+        <p:cNvPr id="1" name="">
+          <a:extLst>
+            <a:ext uri="{FF2B5EF4-FFF2-40B4-BE49-F238E27FC236}">
+              <a16:creationId xmlns:a16="http://schemas.microsoft.com/office/drawing/2014/main" id="{BFE7E845-3357-81A5-4117-983A9D828F1A}"/>
+            </a:ext>
+          </a:extLst>
+        </p:cNvPr>
+        <p:cNvGrpSpPr/>
+        <p:nvPr/>
+      </p:nvGrpSpPr>
+      <p:grpSpPr>
+        <a:xfrm>
+          <a:off x="0" y="0"/>
+          <a:ext cx="0" cy="0"/>
+          <a:chOff x="0" y="0"/>
+          <a:chExt cx="0" cy="0"/>
+        </a:xfrm>
+      </p:grpSpPr>
+      <p:sp>
+        <p:nvSpPr>
+          <p:cNvPr id="2" name="Title 1">
+            <a:extLst>
+              <a:ext uri="{FF2B5EF4-FFF2-40B4-BE49-F238E27FC236}">
+                <a16:creationId xmlns:a16="http://schemas.microsoft.com/office/drawing/2014/main" id="{F249B937-F693-3D88-13D2-0A7364877EF6}"/>
+              </a:ext>
+            </a:extLst>
+          </p:cNvPr>
+          <p:cNvSpPr>
+            <a:spLocks noGrp="1"/>
+          </p:cNvSpPr>
+          <p:nvPr>
+            <p:ph type="title"/>
+          </p:nvPr>
+        </p:nvSpPr>
+        <p:spPr>
+          <a:xfrm>
+            <a:off x="0" y="1307185"/>
+            <a:ext cx="7694818" cy="1325563"/>
+          </a:xfrm>
+        </p:spPr>
+        <p:txBody>
+          <a:bodyPr>
+            <a:normAutofit/>
+          </a:bodyPr>
+          <a:lstStyle/>
+          <a:p>
+            <a:pPr algn="ctr"/>
+            <a:r>
+              <a:rPr lang="en-US" sz="5400" b="1" dirty="0">
+                <a:latin typeface="+mn-lt"/>
+              </a:rPr>
+              <a:t>API Request</a:t>
+            </a:r>
+          </a:p>
+        </p:txBody>
+      </p:sp>
+      <p:sp>
+        <p:nvSpPr>
+          <p:cNvPr id="3" name="Content Placeholder 2">
+            <a:extLst>
+              <a:ext uri="{FF2B5EF4-FFF2-40B4-BE49-F238E27FC236}">
+                <a16:creationId xmlns:a16="http://schemas.microsoft.com/office/drawing/2014/main" id="{7F8B0164-C6FA-D309-2906-7BFC47A28BA4}"/>
+              </a:ext>
+            </a:extLst>
+          </p:cNvPr>
+          <p:cNvSpPr>
+            <a:spLocks noGrp="1"/>
+          </p:cNvSpPr>
+          <p:nvPr>
+            <p:ph idx="1"/>
+          </p:nvPr>
+        </p:nvSpPr>
+        <p:spPr>
+          <a:xfrm>
+            <a:off x="2202964" y="2765842"/>
+            <a:ext cx="3288890" cy="1997586"/>
+          </a:xfrm>
+        </p:spPr>
+        <p:txBody>
+          <a:bodyPr>
+            <a:normAutofit/>
+          </a:bodyPr>
+          <a:lstStyle/>
+          <a:p>
+            <a:pPr>
+              <a:lnSpc>
+                <a:spcPct val="100000"/>
+              </a:lnSpc>
+              <a:spcBef>
+                <a:spcPts val="0"/>
+              </a:spcBef>
+              <a:buFont typeface="Calibri" panose="020F0502020204030204" pitchFamily="34" charset="0"/>
+              <a:buChar char="⁻"/>
+            </a:pPr>
+            <a:r>
+              <a:rPr lang="en-US" dirty="0"/>
+              <a:t>Authorization</a:t>
+            </a:r>
+          </a:p>
+          <a:p>
+            <a:pPr>
+              <a:lnSpc>
+                <a:spcPct val="100000"/>
+              </a:lnSpc>
+              <a:spcBef>
+                <a:spcPts val="0"/>
+              </a:spcBef>
+              <a:buFont typeface="Calibri" panose="020F0502020204030204" pitchFamily="34" charset="0"/>
+              <a:buChar char="⁻"/>
+            </a:pPr>
+            <a:r>
+              <a:rPr lang="en-US" dirty="0"/>
+              <a:t>Path Parameter (Optional)</a:t>
+            </a:r>
+          </a:p>
+          <a:p>
+            <a:pPr>
+              <a:lnSpc>
+                <a:spcPct val="100000"/>
+              </a:lnSpc>
+              <a:spcBef>
+                <a:spcPts val="0"/>
+              </a:spcBef>
+              <a:buFont typeface="Calibri" panose="020F0502020204030204" pitchFamily="34" charset="0"/>
+              <a:buChar char="⁻"/>
+            </a:pPr>
+            <a:r>
+              <a:rPr lang="en-US" dirty="0"/>
+              <a:t>Accept Header (Optional)</a:t>
+            </a:r>
+          </a:p>
+        </p:txBody>
+      </p:sp>
+    </p:spTree>
+    <p:extLst>
+      <p:ext uri="{BB962C8B-B14F-4D97-AF65-F5344CB8AC3E}">
+        <p14:creationId xmlns:p14="http://schemas.microsoft.com/office/powerpoint/2010/main" val="2875060803"/>
+      </p:ext>
+    </p:extLst>
+  </p:cSld>
+  <p:clrMapOvr>
+    <a:masterClrMapping/>
+  </p:clrMapOvr>
+</p:sld>
+</file>
+
+<file path=ppt/slides/slide11.xml><?xml version="1.0" encoding="utf-8"?>
+<p:sld xmlns:a="http://schemas.openxmlformats.org/drawingml/2006/main" xmlns:r="http://schemas.openxmlformats.org/officeDocument/2006/relationships" xmlns:p="http://schemas.openxmlformats.org/presentationml/2006/main">
+  <p:cSld>
     <p:bg>
       <p:bgPr>
         <a:gradFill flip="none" rotWithShape="1">
@@ -6706,7 +6858,7 @@
 </p:sld>
 </file>
 
-<file path=ppt/slides/slide11.xml><?xml version="1.0" encoding="utf-8"?>
+<file path=ppt/slides/slide12.xml><?xml version="1.0" encoding="utf-8"?>
 <p:sld xmlns:a="http://schemas.openxmlformats.org/drawingml/2006/main" xmlns:r="http://schemas.openxmlformats.org/officeDocument/2006/relationships" xmlns:p="http://schemas.openxmlformats.org/presentationml/2006/main">
   <p:cSld>
     <p:spTree>
@@ -6873,7 +7025,7 @@
 </p:sld>
 </file>
 
-<file path=ppt/slides/slide12.xml><?xml version="1.0" encoding="utf-8"?>
+<file path=ppt/slides/slide13.xml><?xml version="1.0" encoding="utf-8"?>
 <p:sld xmlns:a="http://schemas.openxmlformats.org/drawingml/2006/main" xmlns:r="http://schemas.openxmlformats.org/officeDocument/2006/relationships" xmlns:p="http://schemas.openxmlformats.org/presentationml/2006/main">
   <p:cSld>
     <p:bg>
@@ -7455,7 +7607,7 @@
 </p:sld>
 </file>
 
-<file path=ppt/slides/slide13.xml><?xml version="1.0" encoding="utf-8"?>
+<file path=ppt/slides/slide14.xml><?xml version="1.0" encoding="utf-8"?>
 <p:sld xmlns:a="http://schemas.openxmlformats.org/drawingml/2006/main" xmlns:r="http://schemas.openxmlformats.org/officeDocument/2006/relationships" xmlns:p="http://schemas.openxmlformats.org/presentationml/2006/main">
   <p:cSld>
     <p:spTree>
@@ -7734,7 +7886,7 @@
 </p:sld>
 </file>
 
-<file path=ppt/slides/slide14.xml><?xml version="1.0" encoding="utf-8"?>
+<file path=ppt/slides/slide15.xml><?xml version="1.0" encoding="utf-8"?>
 <p:sld xmlns:a="http://schemas.openxmlformats.org/drawingml/2006/main" xmlns:r="http://schemas.openxmlformats.org/officeDocument/2006/relationships" xmlns:p="http://schemas.openxmlformats.org/presentationml/2006/main">
   <p:cSld>
     <p:spTree>
@@ -8250,7 +8402,7 @@
 </p:sld>
 </file>
 
-<file path=ppt/slides/slide15.xml><?xml version="1.0" encoding="utf-8"?>
+<file path=ppt/slides/slide16.xml><?xml version="1.0" encoding="utf-8"?>
 <p:sld xmlns:a="http://schemas.openxmlformats.org/drawingml/2006/main" xmlns:r="http://schemas.openxmlformats.org/officeDocument/2006/relationships" xmlns:p="http://schemas.openxmlformats.org/presentationml/2006/main">
   <p:cSld>
     <p:spTree>
@@ -8394,7 +8546,7 @@
 </p:sld>
 </file>
 
-<file path=ppt/slides/slide16.xml><?xml version="1.0" encoding="utf-8"?>
+<file path=ppt/slides/slide17.xml><?xml version="1.0" encoding="utf-8"?>
 <p:sld xmlns:a="http://schemas.openxmlformats.org/drawingml/2006/main" xmlns:r="http://schemas.openxmlformats.org/officeDocument/2006/relationships" xmlns:p="http://schemas.openxmlformats.org/presentationml/2006/main">
   <p:cSld>
     <p:spTree>
@@ -9105,7 +9257,7 @@
 </p:sld>
 </file>
 
-<file path=ppt/slides/slide17.xml><?xml version="1.0" encoding="utf-8"?>
+<file path=ppt/slides/slide18.xml><?xml version="1.0" encoding="utf-8"?>
 <p:sld xmlns:a="http://schemas.openxmlformats.org/drawingml/2006/main" xmlns:r="http://schemas.openxmlformats.org/officeDocument/2006/relationships" xmlns:p="http://schemas.openxmlformats.org/presentationml/2006/main">
   <p:cSld>
     <p:spTree>
@@ -9272,7 +9424,7 @@
 </p:sld>
 </file>
 
-<file path=ppt/slides/slide18.xml><?xml version="1.0" encoding="utf-8"?>
+<file path=ppt/slides/slide19.xml><?xml version="1.0" encoding="utf-8"?>
 <p:sld xmlns:a="http://schemas.openxmlformats.org/drawingml/2006/main" xmlns:r="http://schemas.openxmlformats.org/officeDocument/2006/relationships" xmlns:p="http://schemas.openxmlformats.org/presentationml/2006/main">
   <p:cSld>
     <p:spTree>
@@ -10158,7 +10310,102 @@
 </p:sld>
 </file>
 
-<file path=ppt/slides/slide19.xml><?xml version="1.0" encoding="utf-8"?>
+<file path=ppt/slides/slide2.xml><?xml version="1.0" encoding="utf-8"?>
+<p:sld xmlns:a="http://schemas.openxmlformats.org/drawingml/2006/main" xmlns:r="http://schemas.openxmlformats.org/officeDocument/2006/relationships" xmlns:p="http://schemas.openxmlformats.org/presentationml/2006/main">
+  <p:cSld>
+    <p:spTree>
+      <p:nvGrpSpPr>
+        <p:cNvPr id="1" name=""/>
+        <p:cNvGrpSpPr/>
+        <p:nvPr/>
+      </p:nvGrpSpPr>
+      <p:grpSpPr>
+        <a:xfrm>
+          <a:off x="0" y="0"/>
+          <a:ext cx="0" cy="0"/>
+          <a:chOff x="0" y="0"/>
+          <a:chExt cx="0" cy="0"/>
+        </a:xfrm>
+      </p:grpSpPr>
+      <p:sp>
+        <p:nvSpPr>
+          <p:cNvPr id="2" name="TextBox 1">
+            <a:extLst>
+              <a:ext uri="{FF2B5EF4-FFF2-40B4-BE49-F238E27FC236}">
+                <a16:creationId xmlns:a16="http://schemas.microsoft.com/office/drawing/2014/main" id="{1ADC34E9-548C-552F-02FF-C8273A0A95A3}"/>
+              </a:ext>
+            </a:extLst>
+          </p:cNvPr>
+          <p:cNvSpPr txBox="1"/>
+          <p:nvPr/>
+        </p:nvSpPr>
+        <p:spPr>
+          <a:xfrm>
+            <a:off x="933062" y="2380879"/>
+            <a:ext cx="9722497" cy="1477328"/>
+          </a:xfrm>
+          <a:prstGeom prst="rect">
+            <a:avLst/>
+          </a:prstGeom>
+          <a:noFill/>
+        </p:spPr>
+        <p:txBody>
+          <a:bodyPr wrap="square" rtlCol="0">
+            <a:spAutoFit/>
+          </a:bodyPr>
+          <a:lstStyle/>
+          <a:p>
+            <a:pPr marL="285750" indent="-285750" algn="just">
+              <a:buFont typeface="Arial" panose="020B0604020202020204" pitchFamily="34" charset="0"/>
+              <a:buChar char="•"/>
+            </a:pPr>
+            <a:r>
+              <a:rPr lang="en-US" dirty="0">
+                <a:solidFill>
+                  <a:srgbClr val="92D050"/>
+                </a:solidFill>
+              </a:rPr>
+              <a:t>Rest Assured </a:t>
+            </a:r>
+            <a:r>
+              <a:rPr lang="en-US" dirty="0"/>
+              <a:t>is a popular open-source Java library designed for testing and validating RESTful web services.</a:t>
+            </a:r>
+          </a:p>
+          <a:p>
+            <a:pPr marL="285750" indent="-285750" algn="just">
+              <a:buFont typeface="Arial" panose="020B0604020202020204" pitchFamily="34" charset="0"/>
+              <a:buChar char="•"/>
+            </a:pPr>
+            <a:endParaRPr lang="en-US" dirty="0"/>
+          </a:p>
+          <a:p>
+            <a:pPr marL="285750" indent="-285750" algn="just">
+              <a:buFont typeface="Arial" panose="020B0604020202020204" pitchFamily="34" charset="0"/>
+              <a:buChar char="•"/>
+            </a:pPr>
+            <a:r>
+              <a:rPr lang="en-US" dirty="0"/>
+              <a:t>It simplifies the process of interacting with APIs, sending various HTTP requests (GET, POST, PUT, DELETE, etc.), and validating the responses received from the server. </a:t>
+            </a:r>
+            <a:endParaRPr lang="en-IN" dirty="0"/>
+          </a:p>
+        </p:txBody>
+      </p:sp>
+    </p:spTree>
+    <p:extLst>
+      <p:ext uri="{BB962C8B-B14F-4D97-AF65-F5344CB8AC3E}">
+        <p14:creationId xmlns:p14="http://schemas.microsoft.com/office/powerpoint/2010/main" val="649189495"/>
+      </p:ext>
+    </p:extLst>
+  </p:cSld>
+  <p:clrMapOvr>
+    <a:masterClrMapping/>
+  </p:clrMapOvr>
+</p:sld>
+</file>
+
+<file path=ppt/slides/slide20.xml><?xml version="1.0" encoding="utf-8"?>
 <p:sld xmlns:a="http://schemas.openxmlformats.org/drawingml/2006/main" xmlns:r="http://schemas.openxmlformats.org/officeDocument/2006/relationships" xmlns:p="http://schemas.openxmlformats.org/presentationml/2006/main">
   <p:cSld>
     <p:spTree>
@@ -10325,102 +10572,7 @@
 </p:sld>
 </file>
 
-<file path=ppt/slides/slide2.xml><?xml version="1.0" encoding="utf-8"?>
-<p:sld xmlns:a="http://schemas.openxmlformats.org/drawingml/2006/main" xmlns:r="http://schemas.openxmlformats.org/officeDocument/2006/relationships" xmlns:p="http://schemas.openxmlformats.org/presentationml/2006/main">
-  <p:cSld>
-    <p:spTree>
-      <p:nvGrpSpPr>
-        <p:cNvPr id="1" name=""/>
-        <p:cNvGrpSpPr/>
-        <p:nvPr/>
-      </p:nvGrpSpPr>
-      <p:grpSpPr>
-        <a:xfrm>
-          <a:off x="0" y="0"/>
-          <a:ext cx="0" cy="0"/>
-          <a:chOff x="0" y="0"/>
-          <a:chExt cx="0" cy="0"/>
-        </a:xfrm>
-      </p:grpSpPr>
-      <p:sp>
-        <p:nvSpPr>
-          <p:cNvPr id="2" name="TextBox 1">
-            <a:extLst>
-              <a:ext uri="{FF2B5EF4-FFF2-40B4-BE49-F238E27FC236}">
-                <a16:creationId xmlns:a16="http://schemas.microsoft.com/office/drawing/2014/main" id="{1ADC34E9-548C-552F-02FF-C8273A0A95A3}"/>
-              </a:ext>
-            </a:extLst>
-          </p:cNvPr>
-          <p:cNvSpPr txBox="1"/>
-          <p:nvPr/>
-        </p:nvSpPr>
-        <p:spPr>
-          <a:xfrm>
-            <a:off x="933062" y="2380879"/>
-            <a:ext cx="9722497" cy="1477328"/>
-          </a:xfrm>
-          <a:prstGeom prst="rect">
-            <a:avLst/>
-          </a:prstGeom>
-          <a:noFill/>
-        </p:spPr>
-        <p:txBody>
-          <a:bodyPr wrap="square" rtlCol="0">
-            <a:spAutoFit/>
-          </a:bodyPr>
-          <a:lstStyle/>
-          <a:p>
-            <a:pPr marL="285750" indent="-285750" algn="just">
-              <a:buFont typeface="Arial" panose="020B0604020202020204" pitchFamily="34" charset="0"/>
-              <a:buChar char="•"/>
-            </a:pPr>
-            <a:r>
-              <a:rPr lang="en-US" dirty="0">
-                <a:solidFill>
-                  <a:srgbClr val="92D050"/>
-                </a:solidFill>
-              </a:rPr>
-              <a:t>Rest Assured </a:t>
-            </a:r>
-            <a:r>
-              <a:rPr lang="en-US" dirty="0"/>
-              <a:t>is a popular open-source Java library designed for testing and validating RESTful web services.</a:t>
-            </a:r>
-          </a:p>
-          <a:p>
-            <a:pPr marL="285750" indent="-285750" algn="just">
-              <a:buFont typeface="Arial" panose="020B0604020202020204" pitchFamily="34" charset="0"/>
-              <a:buChar char="•"/>
-            </a:pPr>
-            <a:endParaRPr lang="en-US" dirty="0"/>
-          </a:p>
-          <a:p>
-            <a:pPr marL="285750" indent="-285750" algn="just">
-              <a:buFont typeface="Arial" panose="020B0604020202020204" pitchFamily="34" charset="0"/>
-              <a:buChar char="•"/>
-            </a:pPr>
-            <a:r>
-              <a:rPr lang="en-US" dirty="0"/>
-              <a:t>It simplifies the process of interacting with APIs, sending various HTTP requests (GET, POST, PUT, DELETE, etc.), and validating the responses received from the server. </a:t>
-            </a:r>
-            <a:endParaRPr lang="en-IN" dirty="0"/>
-          </a:p>
-        </p:txBody>
-      </p:sp>
-    </p:spTree>
-    <p:extLst>
-      <p:ext uri="{BB962C8B-B14F-4D97-AF65-F5344CB8AC3E}">
-        <p14:creationId xmlns:p14="http://schemas.microsoft.com/office/powerpoint/2010/main" val="649189495"/>
-      </p:ext>
-    </p:extLst>
-  </p:cSld>
-  <p:clrMapOvr>
-    <a:masterClrMapping/>
-  </p:clrMapOvr>
-</p:sld>
-</file>
-
-<file path=ppt/slides/slide20.xml><?xml version="1.0" encoding="utf-8"?>
+<file path=ppt/slides/slide21.xml><?xml version="1.0" encoding="utf-8"?>
 <p:sld xmlns:a="http://schemas.openxmlformats.org/drawingml/2006/main" xmlns:r="http://schemas.openxmlformats.org/officeDocument/2006/relationships" xmlns:p="http://schemas.openxmlformats.org/presentationml/2006/main">
   <p:cSld>
     <p:spTree>
@@ -10979,7 +11131,7 @@
 </p:sld>
 </file>
 
-<file path=ppt/slides/slide21.xml><?xml version="1.0" encoding="utf-8"?>
+<file path=ppt/slides/slide22.xml><?xml version="1.0" encoding="utf-8"?>
 <p:sld xmlns:a="http://schemas.openxmlformats.org/drawingml/2006/main" xmlns:r="http://schemas.openxmlformats.org/officeDocument/2006/relationships" xmlns:p="http://schemas.openxmlformats.org/presentationml/2006/main">
   <p:cSld>
     <p:spTree>
@@ -11346,7 +11498,7 @@
 </p:sld>
 </file>
 
-<file path=ppt/slides/slide22.xml><?xml version="1.0" encoding="utf-8"?>
+<file path=ppt/slides/slide23.xml><?xml version="1.0" encoding="utf-8"?>
 <p:sld xmlns:a="http://schemas.openxmlformats.org/drawingml/2006/main" xmlns:r="http://schemas.openxmlformats.org/officeDocument/2006/relationships" xmlns:p="http://schemas.openxmlformats.org/presentationml/2006/main">
   <p:cSld>
     <p:spTree>
@@ -11907,6 +12059,138 @@
 </file>
 
 <file path=ppt/slides/slide5.xml><?xml version="1.0" encoding="utf-8"?>
+<p:sld xmlns:a="http://schemas.openxmlformats.org/drawingml/2006/main" xmlns:r="http://schemas.openxmlformats.org/officeDocument/2006/relationships" xmlns:p="http://schemas.openxmlformats.org/presentationml/2006/main">
+  <p:cSld>
+    <p:spTree>
+      <p:nvGrpSpPr>
+        <p:cNvPr id="1" name="">
+          <a:extLst>
+            <a:ext uri="{FF2B5EF4-FFF2-40B4-BE49-F238E27FC236}">
+              <a16:creationId xmlns:a16="http://schemas.microsoft.com/office/drawing/2014/main" id="{58E9FD67-DDC3-9178-DC36-2201B9BCB1F7}"/>
+            </a:ext>
+          </a:extLst>
+        </p:cNvPr>
+        <p:cNvGrpSpPr/>
+        <p:nvPr/>
+      </p:nvGrpSpPr>
+      <p:grpSpPr>
+        <a:xfrm>
+          <a:off x="0" y="0"/>
+          <a:ext cx="0" cy="0"/>
+          <a:chOff x="0" y="0"/>
+          <a:chExt cx="0" cy="0"/>
+        </a:xfrm>
+      </p:grpSpPr>
+      <p:sp>
+        <p:nvSpPr>
+          <p:cNvPr id="3" name="TextBox 2">
+            <a:extLst>
+              <a:ext uri="{FF2B5EF4-FFF2-40B4-BE49-F238E27FC236}">
+                <a16:creationId xmlns:a16="http://schemas.microsoft.com/office/drawing/2014/main" id="{DCE98DA9-B7F3-FEEE-E99D-548BEE02BAEC}"/>
+              </a:ext>
+            </a:extLst>
+          </p:cNvPr>
+          <p:cNvSpPr txBox="1"/>
+          <p:nvPr/>
+        </p:nvSpPr>
+        <p:spPr>
+          <a:xfrm>
+            <a:off x="503854" y="2362691"/>
+            <a:ext cx="7809722" cy="1200329"/>
+          </a:xfrm>
+          <a:prstGeom prst="rect">
+            <a:avLst/>
+          </a:prstGeom>
+          <a:noFill/>
+        </p:spPr>
+        <p:txBody>
+          <a:bodyPr wrap="square" rtlCol="0">
+            <a:spAutoFit/>
+          </a:bodyPr>
+          <a:lstStyle/>
+          <a:p>
+            <a:r>
+              <a:rPr lang="en-US" dirty="0"/>
+              <a:t>There are two-way approaches to automated the API using RestAssured library</a:t>
+            </a:r>
+          </a:p>
+          <a:p>
+            <a:endParaRPr lang="en-US" dirty="0"/>
+          </a:p>
+          <a:p>
+            <a:pPr marL="342900" indent="-342900">
+              <a:buFont typeface="+mj-lt"/>
+              <a:buAutoNum type="arabicPeriod"/>
+            </a:pPr>
+            <a:r>
+              <a:rPr lang="en-US" dirty="0"/>
+              <a:t>BDD Approach</a:t>
+            </a:r>
+          </a:p>
+          <a:p>
+            <a:pPr marL="342900" indent="-342900">
+              <a:buFont typeface="+mj-lt"/>
+              <a:buAutoNum type="arabicPeriod"/>
+            </a:pPr>
+            <a:r>
+              <a:rPr lang="en-US" dirty="0"/>
+              <a:t>Non BDD Approach</a:t>
+            </a:r>
+            <a:endParaRPr lang="en-IN" dirty="0"/>
+          </a:p>
+        </p:txBody>
+      </p:sp>
+      <p:sp>
+        <p:nvSpPr>
+          <p:cNvPr id="4" name="Title 1">
+            <a:extLst>
+              <a:ext uri="{FF2B5EF4-FFF2-40B4-BE49-F238E27FC236}">
+                <a16:creationId xmlns:a16="http://schemas.microsoft.com/office/drawing/2014/main" id="{F527492D-228A-1669-DE5A-5C2635FF51E3}"/>
+              </a:ext>
+            </a:extLst>
+          </p:cNvPr>
+          <p:cNvSpPr>
+            <a:spLocks noGrp="1"/>
+          </p:cNvSpPr>
+          <p:nvPr>
+            <p:ph type="title"/>
+          </p:nvPr>
+        </p:nvSpPr>
+        <p:spPr>
+          <a:xfrm>
+            <a:off x="401216" y="690466"/>
+            <a:ext cx="8842397" cy="1496520"/>
+          </a:xfrm>
+        </p:spPr>
+        <p:txBody>
+          <a:bodyPr>
+            <a:normAutofit/>
+          </a:bodyPr>
+          <a:lstStyle/>
+          <a:p>
+            <a:r>
+              <a:rPr lang="en-US" sz="5400" b="1" dirty="0">
+                <a:latin typeface="+mn-lt"/>
+              </a:rPr>
+              <a:t>Rest Assured Approach</a:t>
+            </a:r>
+          </a:p>
+        </p:txBody>
+      </p:sp>
+    </p:spTree>
+    <p:extLst>
+      <p:ext uri="{BB962C8B-B14F-4D97-AF65-F5344CB8AC3E}">
+        <p14:creationId xmlns:p14="http://schemas.microsoft.com/office/powerpoint/2010/main" val="2672169298"/>
+      </p:ext>
+    </p:extLst>
+  </p:cSld>
+  <p:clrMapOvr>
+    <a:masterClrMapping/>
+  </p:clrMapOvr>
+</p:sld>
+</file>
+
+<file path=ppt/slides/slide6.xml><?xml version="1.0" encoding="utf-8"?>
 <p:sld xmlns:a="http://schemas.openxmlformats.org/drawingml/2006/main" xmlns:r="http://schemas.openxmlformats.org/officeDocument/2006/relationships" xmlns:p="http://schemas.openxmlformats.org/presentationml/2006/main">
   <p:cSld>
     <p:spTree>
@@ -12340,124 +12624,6 @@
 </p:sld>
 </file>
 
-<file path=ppt/slides/slide6.xml><?xml version="1.0" encoding="utf-8"?>
-<p:sld xmlns:a="http://schemas.openxmlformats.org/drawingml/2006/main" xmlns:r="http://schemas.openxmlformats.org/officeDocument/2006/relationships" xmlns:p="http://schemas.openxmlformats.org/presentationml/2006/main">
-  <p:cSld>
-    <p:spTree>
-      <p:nvGrpSpPr>
-        <p:cNvPr id="1" name=""/>
-        <p:cNvGrpSpPr/>
-        <p:nvPr/>
-      </p:nvGrpSpPr>
-      <p:grpSpPr>
-        <a:xfrm>
-          <a:off x="0" y="0"/>
-          <a:ext cx="0" cy="0"/>
-          <a:chOff x="0" y="0"/>
-          <a:chExt cx="0" cy="0"/>
-        </a:xfrm>
-      </p:grpSpPr>
-      <p:sp>
-        <p:nvSpPr>
-          <p:cNvPr id="2" name="Title 1">
-            <a:extLst>
-              <a:ext uri="{FF2B5EF4-FFF2-40B4-BE49-F238E27FC236}">
-                <a16:creationId xmlns:a16="http://schemas.microsoft.com/office/drawing/2014/main" id="{8309F5A2-23BE-6826-1C31-B59570B4B41E}"/>
-              </a:ext>
-            </a:extLst>
-          </p:cNvPr>
-          <p:cNvSpPr>
-            <a:spLocks noGrp="1"/>
-          </p:cNvSpPr>
-          <p:nvPr>
-            <p:ph type="ctrTitle"/>
-          </p:nvPr>
-        </p:nvSpPr>
-        <p:spPr>
-          <a:xfrm>
-            <a:off x="4242317" y="1143173"/>
-            <a:ext cx="7197726" cy="2421464"/>
-          </a:xfrm>
-        </p:spPr>
-        <p:txBody>
-          <a:bodyPr/>
-          <a:lstStyle/>
-          <a:p>
-            <a:r>
-              <a:rPr lang="en-US" dirty="0"/>
-              <a:t>Performing </a:t>
-            </a:r>
-            <a:r>
-              <a:rPr lang="en-US" b="1" dirty="0">
-                <a:solidFill>
-                  <a:srgbClr val="92D050"/>
-                </a:solidFill>
-              </a:rPr>
-              <a:t>get</a:t>
-            </a:r>
-            <a:r>
-              <a:rPr lang="en-US" dirty="0"/>
-              <a:t> request</a:t>
-            </a:r>
-            <a:endParaRPr lang="en-IN" dirty="0"/>
-          </a:p>
-        </p:txBody>
-      </p:sp>
-      <p:sp>
-        <p:nvSpPr>
-          <p:cNvPr id="3" name="Subtitle 2">
-            <a:extLst>
-              <a:ext uri="{FF2B5EF4-FFF2-40B4-BE49-F238E27FC236}">
-                <a16:creationId xmlns:a16="http://schemas.microsoft.com/office/drawing/2014/main" id="{9B80C28B-675A-C642-8D83-78CAB5202788}"/>
-              </a:ext>
-            </a:extLst>
-          </p:cNvPr>
-          <p:cNvSpPr>
-            <a:spLocks noGrp="1"/>
-          </p:cNvSpPr>
-          <p:nvPr>
-            <p:ph type="subTitle" idx="1"/>
-          </p:nvPr>
-        </p:nvSpPr>
-        <p:spPr>
-          <a:xfrm>
-            <a:off x="4242317" y="3564638"/>
-            <a:ext cx="7197726" cy="1405467"/>
-          </a:xfrm>
-        </p:spPr>
-        <p:txBody>
-          <a:bodyPr/>
-          <a:lstStyle/>
-          <a:p>
-            <a:r>
-              <a:rPr lang="en-US" b="1" dirty="0">
-                <a:solidFill>
-                  <a:srgbClr val="92D050"/>
-                </a:solidFill>
-              </a:rPr>
-              <a:t>Rest Assured Library</a:t>
-            </a:r>
-            <a:endParaRPr lang="en-IN" b="1" dirty="0">
-              <a:solidFill>
-                <a:srgbClr val="92D050"/>
-              </a:solidFill>
-            </a:endParaRPr>
-          </a:p>
-        </p:txBody>
-      </p:sp>
-    </p:spTree>
-    <p:extLst>
-      <p:ext uri="{BB962C8B-B14F-4D97-AF65-F5344CB8AC3E}">
-        <p14:creationId xmlns:p14="http://schemas.microsoft.com/office/powerpoint/2010/main" val="3101987663"/>
-      </p:ext>
-    </p:extLst>
-  </p:cSld>
-  <p:clrMapOvr>
-    <a:masterClrMapping/>
-  </p:clrMapOvr>
-</p:sld>
-</file>
-
 <file path=ppt/slides/slide7.xml><?xml version="1.0" encoding="utf-8"?>
 <p:sld xmlns:a="http://schemas.openxmlformats.org/drawingml/2006/main" xmlns:r="http://schemas.openxmlformats.org/officeDocument/2006/relationships" xmlns:p="http://schemas.openxmlformats.org/presentationml/2006/main">
   <p:cSld>
@@ -12477,6 +12643,124 @@
       </p:grpSpPr>
       <p:sp>
         <p:nvSpPr>
+          <p:cNvPr id="2" name="Title 1">
+            <a:extLst>
+              <a:ext uri="{FF2B5EF4-FFF2-40B4-BE49-F238E27FC236}">
+                <a16:creationId xmlns:a16="http://schemas.microsoft.com/office/drawing/2014/main" id="{8309F5A2-23BE-6826-1C31-B59570B4B41E}"/>
+              </a:ext>
+            </a:extLst>
+          </p:cNvPr>
+          <p:cNvSpPr>
+            <a:spLocks noGrp="1"/>
+          </p:cNvSpPr>
+          <p:nvPr>
+            <p:ph type="ctrTitle"/>
+          </p:nvPr>
+        </p:nvSpPr>
+        <p:spPr>
+          <a:xfrm>
+            <a:off x="4242317" y="1143173"/>
+            <a:ext cx="7197726" cy="2421464"/>
+          </a:xfrm>
+        </p:spPr>
+        <p:txBody>
+          <a:bodyPr/>
+          <a:lstStyle/>
+          <a:p>
+            <a:r>
+              <a:rPr lang="en-US" dirty="0"/>
+              <a:t>Performing </a:t>
+            </a:r>
+            <a:r>
+              <a:rPr lang="en-US" b="1" dirty="0">
+                <a:solidFill>
+                  <a:srgbClr val="92D050"/>
+                </a:solidFill>
+              </a:rPr>
+              <a:t>get</a:t>
+            </a:r>
+            <a:r>
+              <a:rPr lang="en-US" dirty="0"/>
+              <a:t> request</a:t>
+            </a:r>
+            <a:endParaRPr lang="en-IN" dirty="0"/>
+          </a:p>
+        </p:txBody>
+      </p:sp>
+      <p:sp>
+        <p:nvSpPr>
+          <p:cNvPr id="3" name="Subtitle 2">
+            <a:extLst>
+              <a:ext uri="{FF2B5EF4-FFF2-40B4-BE49-F238E27FC236}">
+                <a16:creationId xmlns:a16="http://schemas.microsoft.com/office/drawing/2014/main" id="{9B80C28B-675A-C642-8D83-78CAB5202788}"/>
+              </a:ext>
+            </a:extLst>
+          </p:cNvPr>
+          <p:cNvSpPr>
+            <a:spLocks noGrp="1"/>
+          </p:cNvSpPr>
+          <p:nvPr>
+            <p:ph type="subTitle" idx="1"/>
+          </p:nvPr>
+        </p:nvSpPr>
+        <p:spPr>
+          <a:xfrm>
+            <a:off x="4242317" y="3564638"/>
+            <a:ext cx="7197726" cy="1405467"/>
+          </a:xfrm>
+        </p:spPr>
+        <p:txBody>
+          <a:bodyPr/>
+          <a:lstStyle/>
+          <a:p>
+            <a:r>
+              <a:rPr lang="en-US" b="1" dirty="0">
+                <a:solidFill>
+                  <a:srgbClr val="92D050"/>
+                </a:solidFill>
+              </a:rPr>
+              <a:t>Rest Assured Library</a:t>
+            </a:r>
+            <a:endParaRPr lang="en-IN" b="1" dirty="0">
+              <a:solidFill>
+                <a:srgbClr val="92D050"/>
+              </a:solidFill>
+            </a:endParaRPr>
+          </a:p>
+        </p:txBody>
+      </p:sp>
+    </p:spTree>
+    <p:extLst>
+      <p:ext uri="{BB962C8B-B14F-4D97-AF65-F5344CB8AC3E}">
+        <p14:creationId xmlns:p14="http://schemas.microsoft.com/office/powerpoint/2010/main" val="3101987663"/>
+      </p:ext>
+    </p:extLst>
+  </p:cSld>
+  <p:clrMapOvr>
+    <a:masterClrMapping/>
+  </p:clrMapOvr>
+</p:sld>
+</file>
+
+<file path=ppt/slides/slide8.xml><?xml version="1.0" encoding="utf-8"?>
+<p:sld xmlns:a="http://schemas.openxmlformats.org/drawingml/2006/main" xmlns:r="http://schemas.openxmlformats.org/officeDocument/2006/relationships" xmlns:p="http://schemas.openxmlformats.org/presentationml/2006/main">
+  <p:cSld>
+    <p:spTree>
+      <p:nvGrpSpPr>
+        <p:cNvPr id="1" name=""/>
+        <p:cNvGrpSpPr/>
+        <p:nvPr/>
+      </p:nvGrpSpPr>
+      <p:grpSpPr>
+        <a:xfrm>
+          <a:off x="0" y="0"/>
+          <a:ext cx="0" cy="0"/>
+          <a:chOff x="0" y="0"/>
+          <a:chExt cx="0" cy="0"/>
+        </a:xfrm>
+      </p:grpSpPr>
+      <p:sp>
+        <p:nvSpPr>
           <p:cNvPr id="3" name="TextBox 2">
             <a:extLst>
               <a:ext uri="{FF2B5EF4-FFF2-40B4-BE49-F238E27FC236}">
@@ -12504,8 +12788,12 @@
           <a:lstStyle/>
           <a:p>
             <a:r>
+              <a:rPr lang="en-US" dirty="0" err="1"/>
+              <a:t>RestAssured.given</a:t>
+            </a:r>
+            <a:r>
               <a:rPr lang="en-US" dirty="0"/>
-              <a:t>RestAssured.given()</a:t>
+              <a:t>()</a:t>
             </a:r>
           </a:p>
           <a:p>
@@ -12603,7 +12891,7 @@
 </p:sld>
 </file>
 
-<file path=ppt/slides/slide8.xml><?xml version="1.0" encoding="utf-8"?>
+<file path=ppt/slides/slide9.xml><?xml version="1.0" encoding="utf-8"?>
 <p:sld xmlns:a="http://schemas.openxmlformats.org/drawingml/2006/main" xmlns:r="http://schemas.openxmlformats.org/officeDocument/2006/relationships" xmlns:p="http://schemas.openxmlformats.org/presentationml/2006/main">
   <p:cSld>
     <p:spTree>
@@ -13087,157 +13375,6 @@
     <p:extLst>
       <p:ext uri="{BB962C8B-B14F-4D97-AF65-F5344CB8AC3E}">
         <p14:creationId xmlns:p14="http://schemas.microsoft.com/office/powerpoint/2010/main" val="3196271315"/>
-      </p:ext>
-    </p:extLst>
-  </p:cSld>
-  <p:clrMapOvr>
-    <a:masterClrMapping/>
-  </p:clrMapOvr>
-</p:sld>
-</file>
-
-<file path=ppt/slides/slide9.xml><?xml version="1.0" encoding="utf-8"?>
-<p:sld xmlns:a="http://schemas.openxmlformats.org/drawingml/2006/main" xmlns:r="http://schemas.openxmlformats.org/officeDocument/2006/relationships" xmlns:p="http://schemas.openxmlformats.org/presentationml/2006/main">
-  <p:cSld>
-    <p:spTree>
-      <p:nvGrpSpPr>
-        <p:cNvPr id="1" name="">
-          <a:extLst>
-            <a:ext uri="{FF2B5EF4-FFF2-40B4-BE49-F238E27FC236}">
-              <a16:creationId xmlns:a16="http://schemas.microsoft.com/office/drawing/2014/main" id="{BFE7E845-3357-81A5-4117-983A9D828F1A}"/>
-            </a:ext>
-          </a:extLst>
-        </p:cNvPr>
-        <p:cNvGrpSpPr/>
-        <p:nvPr/>
-      </p:nvGrpSpPr>
-      <p:grpSpPr>
-        <a:xfrm>
-          <a:off x="0" y="0"/>
-          <a:ext cx="0" cy="0"/>
-          <a:chOff x="0" y="0"/>
-          <a:chExt cx="0" cy="0"/>
-        </a:xfrm>
-      </p:grpSpPr>
-      <p:sp>
-        <p:nvSpPr>
-          <p:cNvPr id="2" name="Title 1">
-            <a:extLst>
-              <a:ext uri="{FF2B5EF4-FFF2-40B4-BE49-F238E27FC236}">
-                <a16:creationId xmlns:a16="http://schemas.microsoft.com/office/drawing/2014/main" id="{F249B937-F693-3D88-13D2-0A7364877EF6}"/>
-              </a:ext>
-            </a:extLst>
-          </p:cNvPr>
-          <p:cNvSpPr>
-            <a:spLocks noGrp="1"/>
-          </p:cNvSpPr>
-          <p:nvPr>
-            <p:ph type="title"/>
-          </p:nvPr>
-        </p:nvSpPr>
-        <p:spPr>
-          <a:xfrm>
-            <a:off x="0" y="1307185"/>
-            <a:ext cx="7694818" cy="1325563"/>
-          </a:xfrm>
-        </p:spPr>
-        <p:txBody>
-          <a:bodyPr>
-            <a:normAutofit/>
-          </a:bodyPr>
-          <a:lstStyle/>
-          <a:p>
-            <a:pPr algn="ctr"/>
-            <a:r>
-              <a:rPr lang="en-US" sz="5400" b="1" dirty="0">
-                <a:latin typeface="+mn-lt"/>
-              </a:rPr>
-              <a:t>API Request</a:t>
-            </a:r>
-          </a:p>
-        </p:txBody>
-      </p:sp>
-      <p:sp>
-        <p:nvSpPr>
-          <p:cNvPr id="3" name="Content Placeholder 2">
-            <a:extLst>
-              <a:ext uri="{FF2B5EF4-FFF2-40B4-BE49-F238E27FC236}">
-                <a16:creationId xmlns:a16="http://schemas.microsoft.com/office/drawing/2014/main" id="{7F8B0164-C6FA-D309-2906-7BFC47A28BA4}"/>
-              </a:ext>
-            </a:extLst>
-          </p:cNvPr>
-          <p:cNvSpPr>
-            <a:spLocks noGrp="1"/>
-          </p:cNvSpPr>
-          <p:nvPr>
-            <p:ph idx="1"/>
-          </p:nvPr>
-        </p:nvSpPr>
-        <p:spPr>
-          <a:xfrm>
-            <a:off x="2202964" y="2765842"/>
-            <a:ext cx="3288890" cy="1997586"/>
-          </a:xfrm>
-        </p:spPr>
-        <p:txBody>
-          <a:bodyPr>
-            <a:normAutofit/>
-          </a:bodyPr>
-          <a:lstStyle/>
-          <a:p>
-            <a:pPr>
-              <a:lnSpc>
-                <a:spcPct val="100000"/>
-              </a:lnSpc>
-              <a:spcBef>
-                <a:spcPts val="0"/>
-              </a:spcBef>
-              <a:buFont typeface="Calibri" panose="020F0502020204030204" pitchFamily="34" charset="0"/>
-              <a:buChar char="⁻"/>
-            </a:pPr>
-            <a:r>
-              <a:rPr lang="en-US" dirty="0"/>
-              <a:t>Authorization</a:t>
-            </a:r>
-          </a:p>
-          <a:p>
-            <a:pPr>
-              <a:lnSpc>
-                <a:spcPct val="100000"/>
-              </a:lnSpc>
-              <a:spcBef>
-                <a:spcPts val="0"/>
-              </a:spcBef>
-              <a:buFont typeface="Calibri" panose="020F0502020204030204" pitchFamily="34" charset="0"/>
-              <a:buChar char="⁻"/>
-            </a:pPr>
-            <a:r>
-              <a:rPr lang="en-US" dirty="0"/>
-              <a:t>Path Parameter (Optional)</a:t>
-            </a:r>
-          </a:p>
-          <a:p>
-            <a:pPr>
-              <a:lnSpc>
-                <a:spcPct val="100000"/>
-              </a:lnSpc>
-              <a:spcBef>
-                <a:spcPts val="0"/>
-              </a:spcBef>
-              <a:buFont typeface="Calibri" panose="020F0502020204030204" pitchFamily="34" charset="0"/>
-              <a:buChar char="⁻"/>
-            </a:pPr>
-            <a:r>
-              <a:rPr lang="en-US" dirty="0"/>
-              <a:t>Accept Header (Optional)</a:t>
-            </a:r>
-          </a:p>
-        </p:txBody>
-      </p:sp>
-    </p:spTree>
-    <p:extLst>
-      <p:ext uri="{BB962C8B-B14F-4D97-AF65-F5344CB8AC3E}">
-        <p14:creationId xmlns:p14="http://schemas.microsoft.com/office/powerpoint/2010/main" val="2875060803"/>
       </p:ext>
     </p:extLst>
   </p:cSld>
@@ -13740,15 +13877,6 @@
 </file>
 
 <file path=customXml/item2.xml><?xml version="1.0" encoding="utf-8"?>
-<?mso-contentType ?>
-<FormTemplates xmlns="http://schemas.microsoft.com/sharepoint/v3/contenttype/forms">
-  <Display>DocumentLibraryForm</Display>
-  <Edit>DocumentLibraryForm</Edit>
-  <New>DocumentLibraryForm</New>
-</FormTemplates>
-</file>
-
-<file path=customXml/item3.xml><?xml version="1.0" encoding="utf-8"?>
 <p:properties xmlns:p="http://schemas.microsoft.com/office/2006/metadata/properties" xmlns:xsi="http://www.w3.org/2001/XMLSchema-instance" xmlns:pc="http://schemas.microsoft.com/office/infopath/2007/PartnerControls">
   <documentManagement>
     <lcf76f155ced4ddcb4097134ff3c332f xmlns="6b69fb4e-a79c-4f80-82ef-c95361dd7dc3">
@@ -13757,6 +13885,15 @@
     <TaxCatchAll xmlns="f1491f5c-7a69-4ec9-b2f7-f196c7ec70e0" xsi:nil="true"/>
   </documentManagement>
 </p:properties>
+</file>
+
+<file path=customXml/item3.xml><?xml version="1.0" encoding="utf-8"?>
+<?mso-contentType ?>
+<FormTemplates xmlns="http://schemas.microsoft.com/sharepoint/v3/contenttype/forms">
+  <Display>DocumentLibraryForm</Display>
+  <Edit>DocumentLibraryForm</Edit>
+  <New>DocumentLibraryForm</New>
+</FormTemplates>
 </file>
 
 <file path=customXml/itemProps1.xml><?xml version="1.0" encoding="utf-8"?>
@@ -13779,14 +13916,6 @@
 </file>
 
 <file path=customXml/itemProps2.xml><?xml version="1.0" encoding="utf-8"?>
-<ds:datastoreItem xmlns:ds="http://schemas.openxmlformats.org/officeDocument/2006/customXml" ds:itemID="{B4613125-6242-4F1A-9E76-E2F56394AFDF}">
-  <ds:schemaRefs>
-    <ds:schemaRef ds:uri="http://schemas.microsoft.com/sharepoint/v3/contenttype/forms"/>
-  </ds:schemaRefs>
-</ds:datastoreItem>
-</file>
-
-<file path=customXml/itemProps3.xml><?xml version="1.0" encoding="utf-8"?>
 <ds:datastoreItem xmlns:ds="http://schemas.openxmlformats.org/officeDocument/2006/customXml" ds:itemID="{A3DF73D9-F99D-4A40-BF35-EFC35BA244B0}">
   <ds:schemaRefs>
     <ds:schemaRef ds:uri="http://schemas.microsoft.com/office/2006/metadata/properties"/>
@@ -13795,4 +13924,12 @@
     <ds:schemaRef ds:uri="f1491f5c-7a69-4ec9-b2f7-f196c7ec70e0"/>
   </ds:schemaRefs>
 </ds:datastoreItem>
+</file>
+
+<file path=customXml/itemProps3.xml><?xml version="1.0" encoding="utf-8"?>
+<ds:datastoreItem xmlns:ds="http://schemas.openxmlformats.org/officeDocument/2006/customXml" ds:itemID="{B4613125-6242-4F1A-9E76-E2F56394AFDF}">
+  <ds:schemaRefs>
+    <ds:schemaRef ds:uri="http://schemas.microsoft.com/sharepoint/v3/contenttype/forms"/>
+  </ds:schemaRefs>
+</ds:datastoreItem>
 </file>
</xml_diff>